<commit_message>
docs: 新增 M2 Vision & Scope 文档，更新 M2 PPT 并导出 PDF
</commit_message>
<xml_diff>
--- a/PROJECT-MILESTONE2-第六组-SRE小组-v2.pptx
+++ b/PROJECT-MILESTONE2-第六组-SRE小组-v2.pptx
@@ -5676,8 +5676,8 @@
         </p:nvSpPr>
         <p:spPr>
           <a:xfrm>
-            <a:off x="1280160" y="3063240"/>
-            <a:ext cx="9601200" cy="868680"/>
+            <a:off x="1280160" y="3147060"/>
+            <a:ext cx="9601200" cy="701040"/>
           </a:xfrm>
           <a:prstGeom prst="rect">
             <a:avLst/>
@@ -5702,7 +5702,7 @@
               </a:spcAft>
             </a:pPr>
             <a:r>
-              <a:rPr sz="1400" b="1">
+              <a:rPr sz="2000" b="1">
                 <a:solidFill>
                   <a:srgbClr val="1E3A8A"/>
                 </a:solidFill>
@@ -5713,7 +5713,7 @@
               <a:t>一句话愿景：</a:t>
             </a:r>
             <a:r>
-              <a:rPr sz="1300" b="0">
+              <a:rPr b="0">
                 <a:solidFill>
                   <a:srgbClr val="1F2937"/>
                 </a:solidFill>
@@ -5723,7 +5723,7 @@
               </a:rPr>
               <a:t>把「静态向量检索」升级为可追溯、可解析状态演化的动态记忆系统——不仅召回相关历史，还能判断哪些记忆已过时、被替代或相互冲突，从而给出正确回答。</a:t>
             </a:r>
-            <a:endParaRPr sz="1300" b="0">
+            <a:endParaRPr b="0">
               <a:solidFill>
                 <a:srgbClr val="1F2937"/>
               </a:solidFill>
@@ -5796,8 +5796,8 @@
         </p:nvSpPr>
         <p:spPr>
           <a:xfrm>
-            <a:off x="1097280" y="4480560"/>
-            <a:ext cx="2788920" cy="1554480"/>
+            <a:off x="1097280" y="4429760"/>
+            <a:ext cx="2788920" cy="1134745"/>
           </a:xfrm>
           <a:prstGeom prst="rect">
             <a:avLst/>
@@ -5822,7 +5822,7 @@
               </a:spcAft>
             </a:pPr>
             <a:r>
-              <a:rPr sz="1400" b="1">
+              <a:rPr sz="1600" b="1">
                 <a:solidFill>
                   <a:srgbClr val="1E3A8A"/>
                 </a:solidFill>
@@ -5832,7 +5832,7 @@
               </a:rPr>
               <a:t>① 结构化记忆构建</a:t>
             </a:r>
-            <a:endParaRPr sz="1400" b="1">
+            <a:endParaRPr sz="1600" b="1">
               <a:solidFill>
                 <a:srgbClr val="1E3A8A"/>
               </a:solidFill>
@@ -5854,7 +5854,7 @@
               </a:spcAft>
             </a:pPr>
             <a:r>
-              <a:rPr sz="1200" b="0">
+              <a:rPr sz="1400" b="0">
                 <a:solidFill>
                   <a:srgbClr val="1F2937"/>
                 </a:solidFill>
@@ -5864,7 +5864,7 @@
               </a:rPr>
               <a:t>从 LoCoMo 对话提取人物 / 事件 / 时间 / 状态，生成结构化 Memory，支持统一 JSON 导出。</a:t>
             </a:r>
-            <a:endParaRPr sz="1200" b="0">
+            <a:endParaRPr sz="1400" b="0">
               <a:solidFill>
                 <a:srgbClr val="1F2937"/>
               </a:solidFill>
@@ -5937,8 +5937,8 @@
         </p:nvSpPr>
         <p:spPr>
           <a:xfrm>
-            <a:off x="4690872" y="4480560"/>
-            <a:ext cx="2788920" cy="1554480"/>
+            <a:off x="4690872" y="4357370"/>
+            <a:ext cx="2788920" cy="1134745"/>
           </a:xfrm>
           <a:prstGeom prst="rect">
             <a:avLst/>
@@ -5963,7 +5963,7 @@
               </a:spcAft>
             </a:pPr>
             <a:r>
-              <a:rPr sz="1400" b="1">
+              <a:rPr sz="1600" b="1">
                 <a:solidFill>
                   <a:srgbClr val="1E3A8A"/>
                 </a:solidFill>
@@ -5973,7 +5973,7 @@
               </a:rPr>
               <a:t>② 动态状态解析</a:t>
             </a:r>
-            <a:endParaRPr sz="1400" b="1">
+            <a:endParaRPr sz="1600" b="1">
               <a:solidFill>
                 <a:srgbClr val="1E3A8A"/>
               </a:solidFill>
@@ -5995,7 +5995,7 @@
               </a:spcAft>
             </a:pPr>
             <a:r>
-              <a:rPr sz="1200" b="0">
+              <a:rPr sz="1400" b="0">
                 <a:solidFill>
                   <a:srgbClr val="1F2937"/>
                 </a:solidFill>
@@ -6005,7 +6005,7 @@
               </a:rPr>
               <a:t>判断记忆间 RETAIN / UPDATE / SUPERSEDE / CONFLICT 关系，定位当前有效记忆。</a:t>
             </a:r>
-            <a:endParaRPr sz="1200" b="0">
+            <a:endParaRPr sz="1400" b="0">
               <a:solidFill>
                 <a:srgbClr val="1F2937"/>
               </a:solidFill>
@@ -6078,8 +6078,8 @@
         </p:nvSpPr>
         <p:spPr>
           <a:xfrm>
-            <a:off x="8284464" y="4480560"/>
-            <a:ext cx="2788920" cy="1554480"/>
+            <a:off x="8284464" y="4357370"/>
+            <a:ext cx="2788920" cy="1134745"/>
           </a:xfrm>
           <a:prstGeom prst="rect">
             <a:avLst/>
@@ -6104,7 +6104,7 @@
               </a:spcAft>
             </a:pPr>
             <a:r>
-              <a:rPr sz="1400" b="1">
+              <a:rPr sz="1600" b="1">
                 <a:solidFill>
                   <a:srgbClr val="1E3A8A"/>
                 </a:solidFill>
@@ -6114,7 +6114,7 @@
               </a:rPr>
               <a:t>③ 有效记忆回答</a:t>
             </a:r>
-            <a:endParaRPr sz="1400" b="1">
+            <a:endParaRPr sz="1600" b="1">
               <a:solidFill>
                 <a:srgbClr val="1E3A8A"/>
               </a:solidFill>
@@ -6136,7 +6136,7 @@
               </a:spcAft>
             </a:pPr>
             <a:r>
-              <a:rPr sz="1200" b="0">
+              <a:rPr sz="1400" b="0">
                 <a:solidFill>
                   <a:srgbClr val="1F2937"/>
                 </a:solidFill>
@@ -6146,7 +6146,7 @@
               </a:rPr>
               <a:t>基于当前有效 Memory 生成答案，并在 Web 端展示记忆、证据与解析过程。</a:t>
             </a:r>
-            <a:endParaRPr sz="1200" b="0">
+            <a:endParaRPr sz="1400" b="0">
               <a:solidFill>
                 <a:srgbClr val="1F2937"/>
               </a:solidFill>
@@ -10928,7 +10928,7 @@
         <p:spPr>
           <a:xfrm>
             <a:off x="7498461" y="1572768"/>
-            <a:ext cx="3584448" cy="3692525"/>
+            <a:ext cx="3584448" cy="4385945"/>
           </a:xfrm>
           <a:prstGeom prst="rect">
             <a:avLst/>
@@ -10985,7 +10985,7 @@
               </a:spcAft>
             </a:pPr>
             <a:r>
-              <a:rPr sz="1600" b="1">
+              <a:rPr b="1">
                 <a:solidFill>
                   <a:srgbClr val="2563EB"/>
                 </a:solidFill>
@@ -10995,7 +10995,7 @@
               </a:rPr>
               <a:t>UPDATE 更新</a:t>
             </a:r>
-            <a:endParaRPr sz="1600" b="1">
+            <a:endParaRPr b="1">
               <a:solidFill>
                 <a:srgbClr val="2563EB"/>
               </a:solidFill>
@@ -11017,7 +11017,7 @@
               </a:spcAft>
             </a:pPr>
             <a:r>
-              <a:rPr sz="1400" b="0">
+              <a:rPr sz="1600" b="0">
                 <a:solidFill>
                   <a:srgbClr val="1F2937"/>
                 </a:solidFill>
@@ -11027,7 +11027,7 @@
               </a:rPr>
               <a:t>Caroline：researching → applied → passed adoption。最新阶段为当前有效状态，前序保留为历史。</a:t>
             </a:r>
-            <a:endParaRPr sz="1400" b="0">
+            <a:endParaRPr sz="1600" b="0">
               <a:solidFill>
                 <a:srgbClr val="1F2937"/>
               </a:solidFill>
@@ -11049,7 +11049,7 @@
               </a:spcAft>
             </a:pPr>
             <a:r>
-              <a:rPr sz="1600" b="1">
+              <a:rPr b="1">
                 <a:solidFill>
                   <a:srgbClr val="C85A1E"/>
                 </a:solidFill>
@@ -11059,7 +11059,7 @@
               </a:rPr>
               <a:t>SUPERSEDE 替代</a:t>
             </a:r>
-            <a:endParaRPr sz="1600" b="1">
+            <a:endParaRPr b="1">
               <a:solidFill>
                 <a:srgbClr val="C85A1E"/>
               </a:solidFill>
@@ -11081,7 +11081,7 @@
               </a:spcAft>
             </a:pPr>
             <a:r>
-              <a:rPr sz="1400" b="0">
+              <a:rPr sz="1600" b="0">
                 <a:solidFill>
                   <a:srgbClr val="1F2937"/>
                 </a:solidFill>
@@ -11091,7 +11091,7 @@
               </a:rPr>
               <a:t>Gina：1月失业 DoorDash → 3月网店开业。旧状态被新状态替代，历史事实仍可追溯。</a:t>
             </a:r>
-            <a:endParaRPr sz="1400" b="0">
+            <a:endParaRPr sz="1600" b="0">
               <a:solidFill>
                 <a:srgbClr val="1F2937"/>
               </a:solidFill>
@@ -11113,7 +11113,7 @@
               </a:spcAft>
             </a:pPr>
             <a:r>
-              <a:rPr sz="1600" b="1">
+              <a:rPr b="1">
                 <a:solidFill>
                   <a:srgbClr val="C23B3B"/>
                 </a:solidFill>
@@ -11123,7 +11123,7 @@
               </a:rPr>
               <a:t>CONFLICT 冲突</a:t>
             </a:r>
-            <a:endParaRPr sz="1600" b="1">
+            <a:endParaRPr b="1">
               <a:solidFill>
                 <a:srgbClr val="C23B3B"/>
               </a:solidFill>
@@ -11145,7 +11145,7 @@
               </a:spcAft>
             </a:pPr>
             <a:r>
-              <a:rPr sz="1400" b="0">
+              <a:rPr sz="1600" b="0">
                 <a:solidFill>
                   <a:srgbClr val="1F2937"/>
                 </a:solidFill>
@@ -11155,7 +11155,7 @@
               </a:rPr>
               <a:t>Gina 已失业 vs 仍在 DoorDash 工作。两条当前事实不可同时成立且无充分证据消解 → 标记冲突、暂并存并保留来源。</a:t>
             </a:r>
-            <a:endParaRPr sz="1400" b="0">
+            <a:endParaRPr sz="1600" b="0">
               <a:solidFill>
                 <a:srgbClr val="1F2937"/>
               </a:solidFill>
@@ -11996,7 +11996,7 @@
         </p:nvSpPr>
         <p:spPr>
           <a:xfrm>
-            <a:off x="1261872" y="4828032"/>
+            <a:off x="1216152" y="4822317"/>
             <a:ext cx="9646920" cy="1007745"/>
           </a:xfrm>
           <a:prstGeom prst="rect">
@@ -12138,6 +12138,59 @@
               <a:ea typeface="微软雅黑" panose="020B0503020204020204" charset="-122"/>
               <a:cs typeface="微软雅黑" panose="020B0503020204020204" charset="-122"/>
             </a:endParaRPr>
+          </a:p>
+        </p:txBody>
+      </p:sp>
+      <p:sp>
+        <p:nvSpPr>
+          <p:cNvPr id="10" name="Text Box 9"/>
+          <p:cNvSpPr txBox="1"/>
+          <p:nvPr/>
+        </p:nvSpPr>
+        <p:spPr>
+          <a:xfrm>
+            <a:off x="2133600" y="6198870"/>
+            <a:ext cx="10711815" cy="398780"/>
+          </a:xfrm>
+          <a:prstGeom prst="rect">
+            <a:avLst/>
+          </a:prstGeom>
+          <a:noFill/>
+        </p:spPr>
+        <p:txBody>
+          <a:bodyPr wrap="square" rtlCol="0">
+            <a:spAutoFit/>
+          </a:bodyPr>
+          <a:p>
+            <a:r>
+              <a:rPr lang="zh-CN" altLang="en-US" sz="2000" b="1"/>
+              <a:t>在</a:t>
+            </a:r>
+            <a:r>
+              <a:rPr lang="en-US" altLang="zh-CN" sz="2000" b="1"/>
+              <a:t>M4</a:t>
+            </a:r>
+            <a:r>
+              <a:rPr lang="zh-CN" altLang="en-US" sz="2000" b="1"/>
+              <a:t>之前完成</a:t>
+            </a:r>
+            <a:r>
+              <a:rPr lang="en-US" altLang="zh-CN" sz="2000" b="1"/>
+              <a:t>in-scope</a:t>
+            </a:r>
+            <a:r>
+              <a:rPr lang="zh-CN" altLang="en-US" sz="2000" b="1"/>
+              <a:t>内容，最终版本之前完成所有</a:t>
+            </a:r>
+            <a:r>
+              <a:rPr lang="en-US" altLang="zh-CN" sz="2000" b="1"/>
+              <a:t>bonus</a:t>
+            </a:r>
+            <a:r>
+              <a:rPr lang="zh-CN" altLang="en-US" sz="2000" b="1"/>
+              <a:t>内容</a:t>
+            </a:r>
+            <a:endParaRPr lang="zh-CN" altLang="en-US" sz="2000" b="1"/>
           </a:p>
         </p:txBody>
       </p:sp>
@@ -12405,7 +12458,11 @@
         <p:nvSpPr>
           <p:cNvPr id="7" name="Rounded Rectangle 6"/>
           <p:cNvSpPr/>
-          <p:nvPr/>
+          <p:nvPr>
+            <p:custDataLst>
+              <p:tags r:id="rId1"/>
+            </p:custDataLst>
+          </p:nvPr>
         </p:nvSpPr>
         <p:spPr>
           <a:xfrm>
@@ -12451,7 +12508,11 @@
         <p:nvSpPr>
           <p:cNvPr id="8" name="TextBox 7"/>
           <p:cNvSpPr txBox="1"/>
-          <p:nvPr/>
+          <p:nvPr>
+            <p:custDataLst>
+              <p:tags r:id="rId2"/>
+            </p:custDataLst>
+          </p:nvPr>
         </p:nvSpPr>
         <p:spPr>
           <a:xfrm>
@@ -12592,7 +12653,11 @@
         <p:nvSpPr>
           <p:cNvPr id="9" name="Rounded Rectangle 8"/>
           <p:cNvSpPr/>
-          <p:nvPr/>
+          <p:nvPr>
+            <p:custDataLst>
+              <p:tags r:id="rId3"/>
+            </p:custDataLst>
+          </p:nvPr>
         </p:nvSpPr>
         <p:spPr>
           <a:xfrm>
@@ -12638,7 +12703,11 @@
         <p:nvSpPr>
           <p:cNvPr id="10" name="TextBox 9"/>
           <p:cNvSpPr txBox="1"/>
-          <p:nvPr/>
+          <p:nvPr>
+            <p:custDataLst>
+              <p:tags r:id="rId4"/>
+            </p:custDataLst>
+          </p:nvPr>
         </p:nvSpPr>
         <p:spPr>
           <a:xfrm>
@@ -12725,7 +12794,11 @@
         <p:nvSpPr>
           <p:cNvPr id="11" name="Rounded Rectangle 10"/>
           <p:cNvSpPr/>
-          <p:nvPr/>
+          <p:nvPr>
+            <p:custDataLst>
+              <p:tags r:id="rId5"/>
+            </p:custDataLst>
+          </p:nvPr>
         </p:nvSpPr>
         <p:spPr>
           <a:xfrm>
@@ -12771,7 +12844,11 @@
         <p:nvSpPr>
           <p:cNvPr id="12" name="TextBox 11"/>
           <p:cNvSpPr txBox="1"/>
-          <p:nvPr/>
+          <p:nvPr>
+            <p:custDataLst>
+              <p:tags r:id="rId6"/>
+            </p:custDataLst>
+          </p:nvPr>
         </p:nvSpPr>
         <p:spPr>
           <a:xfrm>
@@ -12803,7 +12880,7 @@
             <a:r>
               <a:rPr sz="2000" b="1">
                 <a:solidFill>
-                  <a:srgbClr val="1E3A8A"/>
+                  <a:srgbClr val="FF0000"/>
                 </a:solidFill>
                 <a:latin typeface="微软雅黑" panose="020B0503020204020204" charset="-122"/>
                 <a:ea typeface="微软雅黑" panose="020B0503020204020204" charset="-122"/>
@@ -12813,7 +12890,7 @@
             </a:r>
             <a:endParaRPr sz="2000" b="1">
               <a:solidFill>
-                <a:srgbClr val="1E3A8A"/>
+                <a:srgbClr val="FF0000"/>
               </a:solidFill>
               <a:latin typeface="微软雅黑" panose="020B0503020204020204" charset="-122"/>
               <a:ea typeface="微软雅黑" panose="020B0503020204020204" charset="-122"/>
@@ -12912,7 +12989,11 @@
         <p:nvSpPr>
           <p:cNvPr id="13" name="Rounded Rectangle 12"/>
           <p:cNvSpPr/>
-          <p:nvPr/>
+          <p:nvPr>
+            <p:custDataLst>
+              <p:tags r:id="rId7"/>
+            </p:custDataLst>
+          </p:nvPr>
         </p:nvSpPr>
         <p:spPr>
           <a:xfrm>
@@ -12958,7 +13039,11 @@
         <p:nvSpPr>
           <p:cNvPr id="14" name="TextBox 13"/>
           <p:cNvSpPr txBox="1"/>
-          <p:nvPr/>
+          <p:nvPr>
+            <p:custDataLst>
+              <p:tags r:id="rId8"/>
+            </p:custDataLst>
+          </p:nvPr>
         </p:nvSpPr>
         <p:spPr>
           <a:xfrm>
@@ -14284,7 +14369,7 @@
         <p:spPr>
           <a:xfrm>
             <a:off x="1133856" y="4041648"/>
-            <a:ext cx="5806440" cy="1024890"/>
+            <a:ext cx="5806440" cy="1372235"/>
           </a:xfrm>
           <a:prstGeom prst="rect">
             <a:avLst/>
@@ -14309,9 +14394,9 @@
               </a:spcAft>
             </a:pPr>
             <a:r>
-              <a:rPr sz="1400" b="1">
-                <a:solidFill>
-                  <a:srgbClr val="1E3A8A"/>
+              <a:rPr sz="1600" b="1">
+                <a:solidFill>
+                  <a:srgbClr val="FF0000"/>
                 </a:solidFill>
                 <a:latin typeface="微软雅黑" panose="020B0503020204020204" charset="-122"/>
                 <a:ea typeface="微软雅黑" panose="020B0503020204020204" charset="-122"/>
@@ -14319,9 +14404,9 @@
               </a:rPr>
               <a:t>推进方式</a:t>
             </a:r>
-            <a:endParaRPr sz="1400" b="1">
+            <a:endParaRPr sz="1600" b="1">
               <a:solidFill>
-                <a:srgbClr val="1E3A8A"/>
+                <a:srgbClr val="FF0000"/>
               </a:solidFill>
               <a:latin typeface="微软雅黑" panose="020B0503020204020204" charset="-122"/>
               <a:ea typeface="微软雅黑" panose="020B0503020204020204" charset="-122"/>
@@ -14341,7 +14426,7 @@
               </a:spcAft>
             </a:pPr>
             <a:r>
-              <a:rPr sz="1150" b="0">
+              <a:rPr sz="1200" b="0">
                 <a:solidFill>
                   <a:srgbClr val="1F2937"/>
                 </a:solidFill>
@@ -14351,7 +14436,7 @@
               </a:rPr>
               <a:t>· 每里程碑至少两轮迭代（初稿 → 评审 → 修订定稿），截止前预留 1–2 天 buffer。</a:t>
             </a:r>
-            <a:endParaRPr sz="1150" b="0">
+            <a:endParaRPr sz="1200" b="0">
               <a:solidFill>
                 <a:srgbClr val="1F2937"/>
               </a:solidFill>
@@ -14373,7 +14458,7 @@
               </a:spcAft>
             </a:pPr>
             <a:r>
-              <a:rPr sz="1150" b="0">
+              <a:rPr sz="1200" b="0">
                 <a:solidFill>
                   <a:srgbClr val="1F2937"/>
                 </a:solidFill>
@@ -14383,7 +14468,83 @@
               </a:rPr>
               <a:t>· 阶段一（10/8–10/10）M1+M2；阶段二（10/11–10/24）M3+M4；阶段三（10/25–11/9）M5。</a:t>
             </a:r>
-            <a:endParaRPr sz="1150" b="0">
+            <a:endParaRPr sz="1200" b="0">
+              <a:solidFill>
+                <a:srgbClr val="1F2937"/>
+              </a:solidFill>
+              <a:latin typeface="微软雅黑" panose="020B0503020204020204" charset="-122"/>
+              <a:ea typeface="微软雅黑" panose="020B0503020204020204" charset="-122"/>
+              <a:cs typeface="微软雅黑" panose="020B0503020204020204" charset="-122"/>
+            </a:endParaRPr>
+          </a:p>
+          <a:p>
+            <a:pPr algn="l">
+              <a:lnSpc>
+                <a:spcPct val="120000"/>
+              </a:lnSpc>
+              <a:spcBef>
+                <a:spcPts val="0"/>
+              </a:spcBef>
+              <a:spcAft>
+                <a:spcPts val="500"/>
+              </a:spcAft>
+            </a:pPr>
+            <a:r>
+              <a:rPr lang="zh-CN" sz="1200" b="0">
+                <a:solidFill>
+                  <a:srgbClr val="1F2937"/>
+                </a:solidFill>
+                <a:latin typeface="微软雅黑" panose="020B0503020204020204" charset="-122"/>
+                <a:ea typeface="微软雅黑" panose="020B0503020204020204" charset="-122"/>
+                <a:cs typeface="微软雅黑" panose="020B0503020204020204" charset="-122"/>
+              </a:rPr>
+              <a:t>阶段二之前完成</a:t>
+            </a:r>
+            <a:r>
+              <a:rPr lang="en-US" altLang="zh-CN" sz="1200" b="0">
+                <a:solidFill>
+                  <a:srgbClr val="1F2937"/>
+                </a:solidFill>
+                <a:latin typeface="微软雅黑" panose="020B0503020204020204" charset="-122"/>
+                <a:ea typeface="微软雅黑" panose="020B0503020204020204" charset="-122"/>
+                <a:cs typeface="微软雅黑" panose="020B0503020204020204" charset="-122"/>
+              </a:rPr>
+              <a:t>inscope</a:t>
+            </a:r>
+            <a:r>
+              <a:rPr lang="zh-CN" altLang="en-US" sz="1200" b="0">
+                <a:solidFill>
+                  <a:srgbClr val="1F2937"/>
+                </a:solidFill>
+                <a:latin typeface="微软雅黑" panose="020B0503020204020204" charset="-122"/>
+                <a:ea typeface="微软雅黑" panose="020B0503020204020204" charset="-122"/>
+                <a:cs typeface="微软雅黑" panose="020B0503020204020204" charset="-122"/>
+              </a:rPr>
+              <a:t>内容，阶段三之前完成</a:t>
+            </a:r>
+            <a:r>
+              <a:rPr lang="en-US" altLang="zh-CN" sz="1200" b="0">
+                <a:solidFill>
+                  <a:srgbClr val="1F2937"/>
+                </a:solidFill>
+                <a:latin typeface="微软雅黑" panose="020B0503020204020204" charset="-122"/>
+                <a:ea typeface="微软雅黑" panose="020B0503020204020204" charset="-122"/>
+                <a:cs typeface="微软雅黑" panose="020B0503020204020204" charset="-122"/>
+              </a:rPr>
+              <a:t>bonus,</a:t>
+            </a:r>
+            <a:r>
+              <a:rPr lang="zh-CN" altLang="en-US" sz="1200" b="0">
+                <a:solidFill>
+                  <a:srgbClr val="1F2937"/>
+                </a:solidFill>
+                <a:latin typeface="微软雅黑" panose="020B0503020204020204" charset="-122"/>
+                <a:ea typeface="微软雅黑" panose="020B0503020204020204" charset="-122"/>
+                <a:cs typeface="微软雅黑" panose="020B0503020204020204" charset="-122"/>
+              </a:rPr>
+              <a:t>并集成完毕。</a:t>
+            </a:r>
+            <a:endParaRPr lang="zh-CN" altLang="en-US" sz="1200" b="0">
               <a:solidFill>
                 <a:srgbClr val="1F2937"/>
               </a:solidFill>
@@ -14959,9 +15120,57 @@
 </p:tagLst>
 </file>
 
+<file path=ppt/tags/tag16.xml><?xml version="1.0" encoding="utf-8"?>
+<p:tagLst xmlns:p="http://schemas.openxmlformats.org/presentationml/2006/main">
+  <p:tag name="KSO_WM_DIAGRAM_VIRTUALLY_FRAME" val="{&quot;height&quot;:381.6,&quot;left&quot;:64.8,&quot;top&quot;:104.4,&quot;width&quot;:830.1600000000001}"/>
+</p:tagLst>
+</file>
+
+<file path=ppt/tags/tag17.xml><?xml version="1.0" encoding="utf-8"?>
+<p:tagLst xmlns:p="http://schemas.openxmlformats.org/presentationml/2006/main">
+  <p:tag name="KSO_WM_DIAGRAM_VIRTUALLY_FRAME" val="{&quot;height&quot;:381.6,&quot;left&quot;:64.8,&quot;top&quot;:104.4,&quot;width&quot;:830.1600000000001}"/>
+</p:tagLst>
+</file>
+
+<file path=ppt/tags/tag18.xml><?xml version="1.0" encoding="utf-8"?>
+<p:tagLst xmlns:p="http://schemas.openxmlformats.org/presentationml/2006/main">
+  <p:tag name="KSO_WM_DIAGRAM_VIRTUALLY_FRAME" val="{&quot;height&quot;:381.6,&quot;left&quot;:64.8,&quot;top&quot;:104.4,&quot;width&quot;:830.1600000000001}"/>
+</p:tagLst>
+</file>
+
+<file path=ppt/tags/tag19.xml><?xml version="1.0" encoding="utf-8"?>
+<p:tagLst xmlns:p="http://schemas.openxmlformats.org/presentationml/2006/main">
+  <p:tag name="KSO_WM_DIAGRAM_VIRTUALLY_FRAME" val="{&quot;height&quot;:381.6,&quot;left&quot;:64.8,&quot;top&quot;:104.4,&quot;width&quot;:830.1600000000001}"/>
+</p:tagLst>
+</file>
+
 <file path=ppt/tags/tag2.xml><?xml version="1.0" encoding="utf-8"?>
 <p:tagLst xmlns:p="http://schemas.openxmlformats.org/presentationml/2006/main">
   <p:tag name="KSO_WM_DIAGRAM_VIRTUALLY_FRAME" val="{&quot;height&quot;:154.8,&quot;left&quot;:64.8,&quot;top&quot;:334.8,&quot;width&quot;:828.72}"/>
+</p:tagLst>
+</file>
+
+<file path=ppt/tags/tag20.xml><?xml version="1.0" encoding="utf-8"?>
+<p:tagLst xmlns:p="http://schemas.openxmlformats.org/presentationml/2006/main">
+  <p:tag name="KSO_WM_DIAGRAM_VIRTUALLY_FRAME" val="{&quot;height&quot;:381.6,&quot;left&quot;:64.8,&quot;top&quot;:104.4,&quot;width&quot;:830.1600000000001}"/>
+</p:tagLst>
+</file>
+
+<file path=ppt/tags/tag21.xml><?xml version="1.0" encoding="utf-8"?>
+<p:tagLst xmlns:p="http://schemas.openxmlformats.org/presentationml/2006/main">
+  <p:tag name="KSO_WM_DIAGRAM_VIRTUALLY_FRAME" val="{&quot;height&quot;:381.6,&quot;left&quot;:64.8,&quot;top&quot;:104.4,&quot;width&quot;:830.1600000000001}"/>
+</p:tagLst>
+</file>
+
+<file path=ppt/tags/tag22.xml><?xml version="1.0" encoding="utf-8"?>
+<p:tagLst xmlns:p="http://schemas.openxmlformats.org/presentationml/2006/main">
+  <p:tag name="KSO_WM_DIAGRAM_VIRTUALLY_FRAME" val="{&quot;height&quot;:381.6,&quot;left&quot;:64.8,&quot;top&quot;:104.4,&quot;width&quot;:830.1600000000001}"/>
+</p:tagLst>
+</file>
+
+<file path=ppt/tags/tag23.xml><?xml version="1.0" encoding="utf-8"?>
+<p:tagLst xmlns:p="http://schemas.openxmlformats.org/presentationml/2006/main">
+  <p:tag name="KSO_WM_DIAGRAM_VIRTUALLY_FRAME" val="{&quot;height&quot;:381.6,&quot;left&quot;:64.8,&quot;top&quot;:104.4,&quot;width&quot;:830.1600000000001}"/>
 </p:tagLst>
 </file>
 

</xml_diff>